<commit_message>
Complete T-028 real OpenJudge mock exam mapping
</commit_message>
<xml_diff>
--- a/courseware/202609_ADS_W05_October_Exam_Review.pptx
+++ b/courseware/202609_ADS_W05_October_Exam_Review.pptx
@@ -6230,7 +6230,7 @@
                 <a:ea typeface="Microsoft YaHei" pitchFamily="34" charset="-122"/>
                 <a:cs typeface="Microsoft YaHei" pitchFamily="34" charset="-120"/>
               </a:rPr>
-              <a:t>T1</a:t>
+              <a:t>E29895</a:t>
             </a:r>
             <a:endParaRPr lang="en-US" sz="1300" dirty="0"/>
           </a:p>
@@ -6308,7 +6308,7 @@
                 <a:ea typeface="Microsoft YaHei" pitchFamily="34" charset="-122"/>
                 <a:cs typeface="Microsoft YaHei" pitchFamily="34" charset="-120"/>
               </a:rPr>
-              <a:t>签到：读入与格式化输出</a:t>
+              <a:t>分解因数 · 试除</a:t>
             </a:r>
             <a:endParaRPr lang="en-US" sz="1250" dirty="0"/>
           </a:p>
@@ -6369,7 +6369,7 @@
                 <a:ea typeface="Microsoft YaHei" pitchFamily="34" charset="-122"/>
                 <a:cs typeface="Microsoft YaHei" pitchFamily="34" charset="-120"/>
               </a:rPr>
-              <a:t>95% 应 AC</a:t>
+              <a:t>真实题</a:t>
             </a:r>
             <a:endParaRPr lang="en-US" sz="1100" dirty="0"/>
           </a:p>
@@ -6430,7 +6430,7 @@
                 <a:ea typeface="Microsoft YaHei" pitchFamily="34" charset="-122"/>
                 <a:cs typeface="Microsoft YaHei" pitchFamily="34" charset="-120"/>
               </a:rPr>
-              <a:t>T2</a:t>
+              <a:t>E29940</a:t>
             </a:r>
             <a:endParaRPr lang="en-US" sz="1300" dirty="0"/>
           </a:p>
@@ -6508,7 +6508,7 @@
                 <a:ea typeface="Microsoft YaHei" pitchFamily="34" charset="-122"/>
                 <a:cs typeface="Microsoft YaHei" pitchFamily="34" charset="-120"/>
               </a:rPr>
-              <a:t>字符串处理</a:t>
+              <a:t>机器猫斗恶龙 · 贪心</a:t>
             </a:r>
             <a:endParaRPr lang="en-US" sz="1250" dirty="0"/>
           </a:p>
@@ -6569,7 +6569,7 @@
                 <a:ea typeface="Microsoft YaHei" pitchFamily="34" charset="-122"/>
                 <a:cs typeface="Microsoft YaHei" pitchFamily="34" charset="-120"/>
               </a:rPr>
-              <a:t>75% AC</a:t>
+              <a:t>真实题</a:t>
             </a:r>
             <a:endParaRPr lang="en-US" sz="1100" dirty="0"/>
           </a:p>
@@ -6630,7 +6630,7 @@
                 <a:ea typeface="Microsoft YaHei" pitchFamily="34" charset="-122"/>
                 <a:cs typeface="Microsoft YaHei" pitchFamily="34" charset="-120"/>
               </a:rPr>
-              <a:t>T3</a:t>
+              <a:t>M29917</a:t>
             </a:r>
             <a:endParaRPr lang="en-US" sz="1300" dirty="0"/>
           </a:p>
@@ -6708,7 +6708,7 @@
                 <a:ea typeface="Microsoft YaHei" pitchFamily="34" charset="-122"/>
                 <a:cs typeface="Microsoft YaHei" pitchFamily="34" charset="-120"/>
               </a:rPr>
-              <a:t>字典 / 排序 + 多关键字</a:t>
+              <a:t>牛顿迭代法 · 浮点</a:t>
             </a:r>
             <a:endParaRPr lang="en-US" sz="1250" dirty="0"/>
           </a:p>
@@ -6769,7 +6769,7 @@
                 <a:ea typeface="Microsoft YaHei" pitchFamily="34" charset="-122"/>
                 <a:cs typeface="Microsoft YaHei" pitchFamily="34" charset="-120"/>
               </a:rPr>
-              <a:t>55% AC</a:t>
+              <a:t>真实题</a:t>
             </a:r>
             <a:endParaRPr lang="en-US" sz="1100" dirty="0"/>
           </a:p>
@@ -6830,7 +6830,7 @@
                 <a:ea typeface="Microsoft YaHei" pitchFamily="34" charset="-122"/>
                 <a:cs typeface="Microsoft YaHei" pitchFamily="34" charset="-120"/>
               </a:rPr>
-              <a:t>T4</a:t>
+              <a:t>M29918</a:t>
             </a:r>
             <a:endParaRPr lang="en-US" sz="1300" dirty="0"/>
           </a:p>
@@ -6908,7 +6908,7 @@
                 <a:ea typeface="Microsoft YaHei" pitchFamily="34" charset="-122"/>
                 <a:cs typeface="Microsoft YaHei" pitchFamily="34" charset="-120"/>
               </a:rPr>
-              <a:t>复杂度意识：必须用筛或前缀和</a:t>
+              <a:t>求亲和数 · 数论</a:t>
             </a:r>
             <a:endParaRPr lang="en-US" sz="1250" dirty="0"/>
           </a:p>
@@ -6969,7 +6969,7 @@
                 <a:ea typeface="Microsoft YaHei" pitchFamily="34" charset="-122"/>
                 <a:cs typeface="Microsoft YaHei" pitchFamily="34" charset="-120"/>
               </a:rPr>
-              <a:t>45% AC</a:t>
+              <a:t>真实题</a:t>
             </a:r>
             <a:endParaRPr lang="en-US" sz="1100" dirty="0"/>
           </a:p>
@@ -7030,7 +7030,7 @@
                 <a:ea typeface="Microsoft YaHei" pitchFamily="34" charset="-122"/>
                 <a:cs typeface="Microsoft YaHei" pitchFamily="34" charset="-120"/>
               </a:rPr>
-              <a:t>T5</a:t>
+              <a:t>M29949</a:t>
             </a:r>
             <a:endParaRPr lang="en-US" sz="1300" dirty="0"/>
           </a:p>
@@ -7108,7 +7108,7 @@
                 <a:ea typeface="Microsoft YaHei" pitchFamily="34" charset="-122"/>
                 <a:cs typeface="Microsoft YaHei" pitchFamily="34" charset="-120"/>
               </a:rPr>
-              <a:t>综合模拟，边界多</a:t>
+              <a:t>贪婪的哥布林 · 分数背包</a:t>
             </a:r>
             <a:endParaRPr lang="en-US" sz="1250" dirty="0"/>
           </a:p>
@@ -7169,7 +7169,7 @@
                 <a:ea typeface="Microsoft YaHei" pitchFamily="34" charset="-122"/>
                 <a:cs typeface="Microsoft YaHei" pitchFamily="34" charset="-120"/>
               </a:rPr>
-              <a:t>25% AC</a:t>
+              <a:t>真实题</a:t>
             </a:r>
             <a:endParaRPr lang="en-US" sz="1100" dirty="0"/>
           </a:p>
@@ -7230,7 +7230,7 @@
                 <a:ea typeface="Microsoft YaHei" pitchFamily="34" charset="-122"/>
                 <a:cs typeface="Microsoft YaHei" pitchFamily="34" charset="-120"/>
               </a:rPr>
-              <a:t>T6</a:t>
+              <a:t>T29947</a:t>
             </a:r>
             <a:endParaRPr lang="en-US" sz="1300" dirty="0"/>
           </a:p>
@@ -7308,7 +7308,7 @@
                 <a:ea typeface="Microsoft YaHei" pitchFamily="34" charset="-122"/>
                 <a:cs typeface="Microsoft YaHei" pitchFamily="34" charset="-120"/>
               </a:rPr>
-              <a:t>补码 / 位运算，符号边界密集</a:t>
+              <a:t>校门外的树又来了 · 区间</a:t>
             </a:r>
             <a:endParaRPr lang="en-US" sz="1250" dirty="0"/>
           </a:p>
@@ -7369,7 +7369,7 @@
                 <a:ea typeface="Microsoft YaHei" pitchFamily="34" charset="-122"/>
                 <a:cs typeface="Microsoft YaHei" pitchFamily="34" charset="-120"/>
               </a:rPr>
-              <a:t>20% AC</a:t>
+              <a:t>真实题</a:t>
             </a:r>
             <a:endParaRPr lang="en-US" sz="1100" dirty="0"/>
           </a:p>

</xml_diff>